<commit_message>
Slides: sd-01-026 cover title at 108 px, re-export badged PPTX
Co-Authored-By: Claude Opus 5.5 <noreply@anthropic.com>
Claude-Session: https://claude.ai/code/session_01PmqNRWe4NoiAuhPfHYj9Qq
</commit_message>
<xml_diff>
--- a/system-design-101/vi/lessons/sd-01-026/slides/sd-01-026.pptx
+++ b/system-design-101/vi/lessons/sd-01-026/slides/sd-01-026.pptx
@@ -1794,7 +1794,7 @@
         <p:spPr>
           <a:xfrm>
             <a:off x="914400" y="1524000"/>
-            <a:ext cx="8572500" cy="3810000"/>
+            <a:ext cx="8572500" cy="4972050"/>
           </a:xfrm>
           <a:prstGeom prst="rect">
             <a:avLst/>
@@ -1803,17 +1803,17 @@
           <a:ln/>
         </p:spPr>
         <p:txBody>
-          <a:bodyPr wrap="square" lIns="0" tIns="64008" rIns="0" bIns="-64008" rtlCol="0" anchor="t"/>
+          <a:bodyPr wrap="square" lIns="0" tIns="72009" rIns="0" bIns="-72009" rtlCol="0" anchor="t"/>
           <a:lstStyle/>
           <a:p>
             <a:pPr algn="l" indent="0" marL="0">
               <a:lnSpc>
-                <a:spcPts val="7488"/>
+                <a:spcPts val="8424"/>
               </a:lnSpc>
               <a:buNone/>
             </a:pPr>
             <a:r>
-              <a:rPr lang="en-US" sz="7200" dirty="0" spc="9" kern="0">
+              <a:rPr lang="en-US" sz="8100" dirty="0" spc="11" kern="0">
                 <a:solidFill>
                   <a:srgbClr val="F3EEE3"/>
                 </a:solidFill>
@@ -1824,7 +1824,7 @@
               <a:t>Unicast,</a:t>
             </a:r>
             <a:r>
-              <a:rPr lang="en-US" sz="7200" dirty="0" spc="-3" kern="0">
+              <a:rPr lang="en-US" sz="8100" dirty="0" spc="-1" kern="0">
                 <a:solidFill>
                   <a:srgbClr val="F3EEE3"/>
                 </a:solidFill>
@@ -1835,7 +1835,7 @@
               <a:t> broadcast,</a:t>
             </a:r>
             <a:r>
-              <a:rPr lang="en-US" sz="7200" dirty="0" spc="2" kern="0">
+              <a:rPr lang="en-US" sz="8100" dirty="0" spc="3" kern="0">
                 <a:solidFill>
                   <a:srgbClr val="F3EEE3"/>
                 </a:solidFill>
@@ -1846,7 +1846,7 @@
               <a:t> multicast</a:t>
             </a:r>
             <a:r>
-              <a:rPr lang="en-US" sz="7200" dirty="0" spc="-77" kern="0">
+              <a:rPr lang="en-US" sz="8100" dirty="0" spc="-87" kern="0">
                 <a:solidFill>
                   <a:srgbClr val="F3EEE3"/>
                 </a:solidFill>
@@ -1857,7 +1857,7 @@
               <a:t> và</a:t>
             </a:r>
             <a:r>
-              <a:rPr lang="en-US" sz="7200" dirty="0" spc="1" kern="0">
+              <a:rPr lang="en-US" sz="8100" dirty="0" spc="2" kern="0">
                 <a:solidFill>
                   <a:srgbClr val="F3EEE3"/>
                 </a:solidFill>
@@ -1867,7 +1867,7 @@
               </a:rPr>
               <a:t> anycast</a:t>
             </a:r>
-            <a:endParaRPr lang="en-US" sz="7200" dirty="0"/>
+            <a:endParaRPr lang="en-US" sz="8100" dirty="0"/>
           </a:p>
         </p:txBody>
       </p:sp>
@@ -1879,8 +1879,8 @@
         </p:nvSpPr>
         <p:spPr>
           <a:xfrm>
-            <a:off x="914400" y="4191000"/>
-            <a:ext cx="8382000" cy="1047750"/>
+            <a:off x="914400" y="6286500"/>
+            <a:ext cx="8382000" cy="571500"/>
           </a:xfrm>
           <a:prstGeom prst="rect">
             <a:avLst/>
@@ -1998,7 +1998,7 @@
         </p:nvSpPr>
         <p:spPr>
           <a:xfrm>
-            <a:off x="914400" y="5524500"/>
+            <a:off x="914400" y="7143750"/>
             <a:ext cx="8420100" cy="0"/>
           </a:xfrm>
           <a:prstGeom prst="line">
@@ -2023,7 +2023,7 @@
         </p:nvSpPr>
         <p:spPr>
           <a:xfrm>
-            <a:off x="914400" y="5829300"/>
+            <a:off x="914400" y="7429500"/>
             <a:ext cx="8382000" cy="457200"/>
           </a:xfrm>
           <a:prstGeom prst="rect">

</xml_diff>